<commit_message>
Add proportional control review slides and favor straight()/turn() over timed drives
- Replaced timed arcade() demos in lesson 05 with straight()/turn() examples
  that emphasize sensor-based distance/angle accuracy over time-based driving
- Added proportional control review slide deck (outline + pptx) with visual
  analogies, worked examples, and interactive trace-through exercises
- Included build script for regenerating the review pptx

Co-Authored-By: Claude Opus 4.6 <noreply@anthropic.com>
</commit_message>
<xml_diff>
--- a/module-02-line-tracking/slides/09-object-composition.pptx
+++ b/module-02-line-tracking/slides/09-object-composition.pptx
@@ -78,7 +78,7 @@
         <a:sym typeface="Calibri"/>
       </a:defRPr>
     </a:lvl1pPr>
-    <a:lvl2pPr marL="0" marR="0" indent="457200" algn="l" defTabSz="457200" rtl="0" fontAlgn="auto" latinLnBrk="0" hangingPunct="0">
+    <a:lvl2pPr marL="0" marR="0" indent="0" algn="l" defTabSz="457200" rtl="0" fontAlgn="auto" latinLnBrk="0" hangingPunct="0">
       <a:lnSpc>
         <a:spcPct val="100000"/>
       </a:lnSpc>
@@ -108,7 +108,7 @@
         <a:sym typeface="Calibri"/>
       </a:defRPr>
     </a:lvl2pPr>
-    <a:lvl3pPr marL="0" marR="0" indent="914400" algn="l" defTabSz="457200" rtl="0" fontAlgn="auto" latinLnBrk="0" hangingPunct="0">
+    <a:lvl3pPr marL="0" marR="0" indent="0" algn="l" defTabSz="457200" rtl="0" fontAlgn="auto" latinLnBrk="0" hangingPunct="0">
       <a:lnSpc>
         <a:spcPct val="100000"/>
       </a:lnSpc>
@@ -138,7 +138,7 @@
         <a:sym typeface="Calibri"/>
       </a:defRPr>
     </a:lvl3pPr>
-    <a:lvl4pPr marL="0" marR="0" indent="1371600" algn="l" defTabSz="457200" rtl="0" fontAlgn="auto" latinLnBrk="0" hangingPunct="0">
+    <a:lvl4pPr marL="0" marR="0" indent="0" algn="l" defTabSz="457200" rtl="0" fontAlgn="auto" latinLnBrk="0" hangingPunct="0">
       <a:lnSpc>
         <a:spcPct val="100000"/>
       </a:lnSpc>
@@ -168,7 +168,7 @@
         <a:sym typeface="Calibri"/>
       </a:defRPr>
     </a:lvl4pPr>
-    <a:lvl5pPr marL="0" marR="0" indent="1828800" algn="l" defTabSz="457200" rtl="0" fontAlgn="auto" latinLnBrk="0" hangingPunct="0">
+    <a:lvl5pPr marL="0" marR="0" indent="0" algn="l" defTabSz="457200" rtl="0" fontAlgn="auto" latinLnBrk="0" hangingPunct="0">
       <a:lnSpc>
         <a:spcPct val="100000"/>
       </a:lnSpc>
@@ -198,7 +198,7 @@
         <a:sym typeface="Calibri"/>
       </a:defRPr>
     </a:lvl5pPr>
-    <a:lvl6pPr marL="0" marR="0" indent="2286000" algn="l" defTabSz="457200" rtl="0" fontAlgn="auto" latinLnBrk="0" hangingPunct="0">
+    <a:lvl6pPr marL="0" marR="0" indent="0" algn="l" defTabSz="457200" rtl="0" fontAlgn="auto" latinLnBrk="0" hangingPunct="0">
       <a:lnSpc>
         <a:spcPct val="100000"/>
       </a:lnSpc>
@@ -228,7 +228,7 @@
         <a:sym typeface="Calibri"/>
       </a:defRPr>
     </a:lvl6pPr>
-    <a:lvl7pPr marL="0" marR="0" indent="2743200" algn="l" defTabSz="457200" rtl="0" fontAlgn="auto" latinLnBrk="0" hangingPunct="0">
+    <a:lvl7pPr marL="0" marR="0" indent="0" algn="l" defTabSz="457200" rtl="0" fontAlgn="auto" latinLnBrk="0" hangingPunct="0">
       <a:lnSpc>
         <a:spcPct val="100000"/>
       </a:lnSpc>
@@ -258,7 +258,7 @@
         <a:sym typeface="Calibri"/>
       </a:defRPr>
     </a:lvl7pPr>
-    <a:lvl8pPr marL="0" marR="0" indent="3200400" algn="l" defTabSz="457200" rtl="0" fontAlgn="auto" latinLnBrk="0" hangingPunct="0">
+    <a:lvl8pPr marL="0" marR="0" indent="0" algn="l" defTabSz="457200" rtl="0" fontAlgn="auto" latinLnBrk="0" hangingPunct="0">
       <a:lnSpc>
         <a:spcPct val="100000"/>
       </a:lnSpc>
@@ -288,7 +288,7 @@
         <a:sym typeface="Calibri"/>
       </a:defRPr>
     </a:lvl8pPr>
-    <a:lvl9pPr marL="0" marR="0" indent="3657600" algn="l" defTabSz="457200" rtl="0" fontAlgn="auto" latinLnBrk="0" hangingPunct="0">
+    <a:lvl9pPr marL="0" marR="0" indent="0" algn="l" defTabSz="457200" rtl="0" fontAlgn="auto" latinLnBrk="0" hangingPunct="0">
       <a:lnSpc>
         <a:spcPct val="100000"/>
       </a:lnSpc>
@@ -548,7 +548,7 @@
                 </a:solidFill>
               </a:defRPr>
             </a:lvl1pPr>
-            <a:lvl2pPr marL="0" indent="457200" algn="ctr">
+            <a:lvl2pPr marL="0" indent="0" algn="ctr">
               <a:buSzTx/>
               <a:buFontTx/>
               <a:buNone/>
@@ -558,7 +558,7 @@
                 </a:solidFill>
               </a:defRPr>
             </a:lvl2pPr>
-            <a:lvl3pPr marL="0" indent="914400" algn="ctr">
+            <a:lvl3pPr marL="0" indent="0" algn="ctr">
               <a:buSzTx/>
               <a:buFontTx/>
               <a:buNone/>
@@ -568,7 +568,7 @@
                 </a:solidFill>
               </a:defRPr>
             </a:lvl3pPr>
-            <a:lvl4pPr marL="0" indent="1371600" algn="ctr">
+            <a:lvl4pPr marL="0" indent="0" algn="ctr">
               <a:buSzTx/>
               <a:buFontTx/>
               <a:buNone/>
@@ -578,7 +578,7 @@
                 </a:solidFill>
               </a:defRPr>
             </a:lvl4pPr>
-            <a:lvl5pPr marL="0" indent="1828800" algn="ctr">
+            <a:lvl5pPr marL="0" indent="0" algn="ctr">
               <a:buSzTx/>
               <a:buFontTx/>
               <a:buNone/>
@@ -678,10 +678,6 @@
           </p:nvPr>
         </p:nvSpPr>
         <p:spPr>
-          <a:xfrm>
-            <a:off x="457200" y="274638"/>
-            <a:ext cx="8229600" cy="1143001"/>
-          </a:xfrm>
           <a:prstGeom prst="rect">
             <a:avLst/>
           </a:prstGeom>
@@ -706,10 +702,6 @@
           </p:nvPr>
         </p:nvSpPr>
         <p:spPr>
-          <a:xfrm>
-            <a:off x="457200" y="1600200"/>
-            <a:ext cx="8229600" cy="4525963"/>
-          </a:xfrm>
           <a:prstGeom prst="rect">
             <a:avLst/>
           </a:prstGeom>
@@ -840,7 +832,7 @@
         <p:spPr>
           <a:xfrm>
             <a:off x="722312" y="2906713"/>
-            <a:ext cx="7772401" cy="1500188"/>
+            <a:ext cx="7772401" cy="1500189"/>
           </a:xfrm>
           <a:prstGeom prst="rect">
             <a:avLst/>
@@ -862,7 +854,7 @@
                 </a:solidFill>
               </a:defRPr>
             </a:lvl1pPr>
-            <a:lvl2pPr marL="0" indent="457200">
+            <a:lvl2pPr marL="0" indent="0">
               <a:spcBef>
                 <a:spcPts val="400"/>
               </a:spcBef>
@@ -875,7 +867,7 @@
                 </a:solidFill>
               </a:defRPr>
             </a:lvl2pPr>
-            <a:lvl3pPr marL="0" indent="914400">
+            <a:lvl3pPr marL="0" indent="0">
               <a:spcBef>
                 <a:spcPts val="400"/>
               </a:spcBef>
@@ -888,7 +880,7 @@
                 </a:solidFill>
               </a:defRPr>
             </a:lvl3pPr>
-            <a:lvl4pPr marL="0" indent="1371600">
+            <a:lvl4pPr marL="0" indent="0">
               <a:spcBef>
                 <a:spcPts val="400"/>
               </a:spcBef>
@@ -901,7 +893,7 @@
                 </a:solidFill>
               </a:defRPr>
             </a:lvl4pPr>
-            <a:lvl5pPr marL="0" indent="1828800">
+            <a:lvl5pPr marL="0" indent="0">
               <a:spcBef>
                 <a:spcPts val="400"/>
               </a:spcBef>
@@ -1004,10 +996,6 @@
           </p:nvPr>
         </p:nvSpPr>
         <p:spPr>
-          <a:xfrm>
-            <a:off x="457200" y="274638"/>
-            <a:ext cx="8229600" cy="1143001"/>
-          </a:xfrm>
           <a:prstGeom prst="rect">
             <a:avLst/>
           </a:prstGeom>
@@ -1055,7 +1043,7 @@
               </a:spcBef>
               <a:defRPr sz="2800"/>
             </a:lvl2pPr>
-            <a:lvl3pPr marL="1234439" indent="-320039">
+            <a:lvl3pPr marL="1234438" indent="-320038">
               <a:spcBef>
                 <a:spcPts val="600"/>
               </a:spcBef>
@@ -1163,10 +1151,6 @@
           </p:nvPr>
         </p:nvSpPr>
         <p:spPr>
-          <a:xfrm>
-            <a:off x="457200" y="274638"/>
-            <a:ext cx="8229600" cy="1143001"/>
-          </a:xfrm>
           <a:prstGeom prst="rect">
             <a:avLst/>
           </a:prstGeom>
@@ -1211,7 +1195,7 @@
               <a:buNone/>
               <a:defRPr b="1" sz="2400"/>
             </a:lvl1pPr>
-            <a:lvl2pPr marL="0" indent="457200">
+            <a:lvl2pPr marL="0" indent="0">
               <a:spcBef>
                 <a:spcPts val="500"/>
               </a:spcBef>
@@ -1220,7 +1204,7 @@
               <a:buNone/>
               <a:defRPr b="1" sz="2400"/>
             </a:lvl2pPr>
-            <a:lvl3pPr marL="0" indent="914400">
+            <a:lvl3pPr marL="0" indent="0">
               <a:spcBef>
                 <a:spcPts val="500"/>
               </a:spcBef>
@@ -1229,7 +1213,7 @@
               <a:buNone/>
               <a:defRPr b="1" sz="2400"/>
             </a:lvl3pPr>
-            <a:lvl4pPr marL="0" indent="1371600">
+            <a:lvl4pPr marL="0" indent="0">
               <a:spcBef>
                 <a:spcPts val="500"/>
               </a:spcBef>
@@ -1238,7 +1222,7 @@
               <a:buNone/>
               <a:defRPr b="1" sz="2400"/>
             </a:lvl4pPr>
-            <a:lvl5pPr marL="0" indent="1828800">
+            <a:lvl5pPr marL="0" indent="0">
               <a:spcBef>
                 <a:spcPts val="500"/>
               </a:spcBef>
@@ -1290,8 +1274,8 @@
         </p:nvSpPr>
         <p:spPr>
           <a:xfrm>
-            <a:off x="4645025" y="1535112"/>
-            <a:ext cx="4041775" cy="639763"/>
+            <a:off x="4645025" y="1535111"/>
+            <a:ext cx="4041775" cy="639765"/>
           </a:xfrm>
           <a:prstGeom prst="rect">
             <a:avLst/>
@@ -1301,15 +1285,7 @@
           <a:bodyPr anchor="b"/>
           <a:lstStyle/>
           <a:p>
-            <a:pPr marL="0" indent="0">
-              <a:spcBef>
-                <a:spcPts val="500"/>
-              </a:spcBef>
-              <a:buSzTx/>
-              <a:buFontTx/>
-              <a:buNone/>
-              <a:defRPr b="1" sz="2400"/>
-            </a:pPr>
+            <a:pPr/>
           </a:p>
         </p:txBody>
       </p:sp>
@@ -1370,10 +1346,6 @@
           </p:nvPr>
         </p:nvSpPr>
         <p:spPr>
-          <a:xfrm>
-            <a:off x="457200" y="274638"/>
-            <a:ext cx="8229600" cy="1143001"/>
-          </a:xfrm>
           <a:prstGeom prst="rect">
             <a:avLst/>
           </a:prstGeom>
@@ -1496,7 +1468,7 @@
         <p:spPr>
           <a:xfrm>
             <a:off x="457200" y="273050"/>
-            <a:ext cx="3008314" cy="1162050"/>
+            <a:ext cx="3008315" cy="1162050"/>
           </a:xfrm>
           <a:prstGeom prst="rect">
             <a:avLst/>
@@ -1579,8 +1551,8 @@
         </p:nvSpPr>
         <p:spPr>
           <a:xfrm>
-            <a:off x="457199" y="1435100"/>
-            <a:ext cx="3008315" cy="4691063"/>
+            <a:off x="457198" y="1435100"/>
+            <a:ext cx="3008316" cy="4691063"/>
           </a:xfrm>
           <a:prstGeom prst="rect">
             <a:avLst/>
@@ -1590,15 +1562,7 @@
           <a:bodyPr/>
           <a:lstStyle/>
           <a:p>
-            <a:pPr marL="0" indent="0">
-              <a:spcBef>
-                <a:spcPts val="300"/>
-              </a:spcBef>
-              <a:buSzTx/>
-              <a:buFontTx/>
-              <a:buNone/>
-              <a:defRPr sz="1400"/>
-            </a:pPr>
+            <a:pPr/>
           </a:p>
         </p:txBody>
       </p:sp>
@@ -1661,7 +1625,7 @@
         <p:spPr>
           <a:xfrm>
             <a:off x="1792288" y="4800600"/>
-            <a:ext cx="5486401" cy="566738"/>
+            <a:ext cx="5486402" cy="566738"/>
           </a:xfrm>
           <a:prstGeom prst="rect">
             <a:avLst/>
@@ -1693,14 +1657,14 @@
         <p:spPr>
           <a:xfrm>
             <a:off x="1792288" y="612775"/>
-            <a:ext cx="5486401" cy="4114800"/>
+            <a:ext cx="5486402" cy="4114800"/>
           </a:xfrm>
           <a:prstGeom prst="rect">
             <a:avLst/>
           </a:prstGeom>
         </p:spPr>
         <p:txBody>
-          <a:bodyPr lIns="91439" rIns="91439">
+          <a:bodyPr lIns="91439" tIns="45719" rIns="91439" bIns="45719">
             <a:noAutofit/>
           </a:bodyPr>
           <a:lstStyle/>
@@ -1720,7 +1684,7 @@
         <p:spPr>
           <a:xfrm>
             <a:off x="1792288" y="5367337"/>
-            <a:ext cx="5486401" cy="804863"/>
+            <a:ext cx="5486402" cy="804864"/>
           </a:xfrm>
           <a:prstGeom prst="rect">
             <a:avLst/>
@@ -1738,7 +1702,7 @@
               <a:buNone/>
               <a:defRPr sz="1400"/>
             </a:lvl1pPr>
-            <a:lvl2pPr marL="0" indent="457200">
+            <a:lvl2pPr marL="0" indent="0">
               <a:spcBef>
                 <a:spcPts val="300"/>
               </a:spcBef>
@@ -1747,7 +1711,7 @@
               <a:buNone/>
               <a:defRPr sz="1400"/>
             </a:lvl2pPr>
-            <a:lvl3pPr marL="0" indent="914400">
+            <a:lvl3pPr marL="0" indent="0">
               <a:spcBef>
                 <a:spcPts val="300"/>
               </a:spcBef>
@@ -1756,7 +1720,7 @@
               <a:buNone/>
               <a:defRPr sz="1400"/>
             </a:lvl3pPr>
-            <a:lvl4pPr marL="0" indent="1371600">
+            <a:lvl4pPr marL="0" indent="0">
               <a:spcBef>
                 <a:spcPts val="300"/>
               </a:spcBef>
@@ -1765,7 +1729,7 @@
               <a:buNone/>
               <a:defRPr sz="1400"/>
             </a:lvl4pPr>
-            <a:lvl5pPr marL="0" indent="1828800">
+            <a:lvl5pPr marL="0" indent="0">
               <a:spcBef>
                 <a:spcPts val="300"/>
               </a:spcBef>
@@ -1872,8 +1836,8 @@
         </p:nvSpPr>
         <p:spPr>
           <a:xfrm>
-            <a:off x="608965" y="92074"/>
-            <a:ext cx="10961370" cy="1508127"/>
+            <a:off x="457200" y="274638"/>
+            <a:ext cx="8229600" cy="1143001"/>
           </a:xfrm>
           <a:prstGeom prst="rect">
             <a:avLst/>
@@ -1888,7 +1852,7 @@
           </a:extLst>
         </p:spPr>
         <p:txBody>
-          <a:bodyPr lIns="45719" rIns="45719" anchor="ctr">
+          <a:bodyPr lIns="45718" tIns="45718" rIns="45718" bIns="45718" anchor="ctr">
             <a:normAutofit fontScale="100000" lnSpcReduction="0"/>
           </a:bodyPr>
           <a:lstStyle/>
@@ -1910,8 +1874,8 @@
         </p:nvSpPr>
         <p:spPr>
           <a:xfrm>
-            <a:off x="608965" y="1600200"/>
-            <a:ext cx="10961370" cy="5257800"/>
+            <a:off x="457200" y="1600200"/>
+            <a:ext cx="8229600" cy="4525963"/>
           </a:xfrm>
           <a:prstGeom prst="rect">
             <a:avLst/>
@@ -1926,7 +1890,7 @@
           </a:extLst>
         </p:spPr>
         <p:txBody>
-          <a:bodyPr lIns="45719" rIns="45719">
+          <a:bodyPr lIns="45718" tIns="45718" rIns="45718" bIns="45718">
             <a:normAutofit fontScale="100000" lnSpcReduction="0"/>
           </a:bodyPr>
           <a:lstStyle/>
@@ -1972,8 +1936,8 @@
         </p:nvSpPr>
         <p:spPr>
           <a:xfrm>
-            <a:off x="8428176" y="6414760"/>
-            <a:ext cx="258624" cy="248305"/>
+            <a:off x="8428178" y="6414761"/>
+            <a:ext cx="258623" cy="248303"/>
           </a:xfrm>
           <a:prstGeom prst="rect">
             <a:avLst/>
@@ -1983,7 +1947,7 @@
           </a:ln>
         </p:spPr>
         <p:txBody>
-          <a:bodyPr wrap="none" lIns="45719" rIns="45719" anchor="ctr">
+          <a:bodyPr wrap="none" lIns="45718" tIns="45718" rIns="45718" bIns="45718" anchor="ctr">
             <a:spAutoFit/>
           </a:bodyPr>
           <a:lstStyle>
@@ -2516,7 +2480,7 @@
           <a:sym typeface="Calibri"/>
         </a:defRPr>
       </a:lvl1pPr>
-      <a:lvl2pPr marL="0" marR="0" indent="457200" algn="r" defTabSz="457200" rtl="0" latinLnBrk="0">
+      <a:lvl2pPr marL="0" marR="0" indent="0" algn="r" defTabSz="457200" rtl="0" latinLnBrk="0">
         <a:lnSpc>
           <a:spcPct val="100000"/>
         </a:lnSpc>
@@ -2542,7 +2506,7 @@
           <a:sym typeface="Calibri"/>
         </a:defRPr>
       </a:lvl2pPr>
-      <a:lvl3pPr marL="0" marR="0" indent="914400" algn="r" defTabSz="457200" rtl="0" latinLnBrk="0">
+      <a:lvl3pPr marL="0" marR="0" indent="0" algn="r" defTabSz="457200" rtl="0" latinLnBrk="0">
         <a:lnSpc>
           <a:spcPct val="100000"/>
         </a:lnSpc>
@@ -2568,7 +2532,7 @@
           <a:sym typeface="Calibri"/>
         </a:defRPr>
       </a:lvl3pPr>
-      <a:lvl4pPr marL="0" marR="0" indent="1371600" algn="r" defTabSz="457200" rtl="0" latinLnBrk="0">
+      <a:lvl4pPr marL="0" marR="0" indent="0" algn="r" defTabSz="457200" rtl="0" latinLnBrk="0">
         <a:lnSpc>
           <a:spcPct val="100000"/>
         </a:lnSpc>
@@ -2594,7 +2558,7 @@
           <a:sym typeface="Calibri"/>
         </a:defRPr>
       </a:lvl4pPr>
-      <a:lvl5pPr marL="0" marR="0" indent="1828800" algn="r" defTabSz="457200" rtl="0" latinLnBrk="0">
+      <a:lvl5pPr marL="0" marR="0" indent="0" algn="r" defTabSz="457200" rtl="0" latinLnBrk="0">
         <a:lnSpc>
           <a:spcPct val="100000"/>
         </a:lnSpc>
@@ -2620,7 +2584,7 @@
           <a:sym typeface="Calibri"/>
         </a:defRPr>
       </a:lvl5pPr>
-      <a:lvl6pPr marL="0" marR="0" indent="2286000" algn="r" defTabSz="457200" rtl="0" latinLnBrk="0">
+      <a:lvl6pPr marL="0" marR="0" indent="0" algn="r" defTabSz="457200" rtl="0" latinLnBrk="0">
         <a:lnSpc>
           <a:spcPct val="100000"/>
         </a:lnSpc>
@@ -2646,7 +2610,7 @@
           <a:sym typeface="Calibri"/>
         </a:defRPr>
       </a:lvl6pPr>
-      <a:lvl7pPr marL="0" marR="0" indent="2743200" algn="r" defTabSz="457200" rtl="0" latinLnBrk="0">
+      <a:lvl7pPr marL="0" marR="0" indent="0" algn="r" defTabSz="457200" rtl="0" latinLnBrk="0">
         <a:lnSpc>
           <a:spcPct val="100000"/>
         </a:lnSpc>
@@ -2672,7 +2636,7 @@
           <a:sym typeface="Calibri"/>
         </a:defRPr>
       </a:lvl7pPr>
-      <a:lvl8pPr marL="0" marR="0" indent="3200400" algn="r" defTabSz="457200" rtl="0" latinLnBrk="0">
+      <a:lvl8pPr marL="0" marR="0" indent="0" algn="r" defTabSz="457200" rtl="0" latinLnBrk="0">
         <a:lnSpc>
           <a:spcPct val="100000"/>
         </a:lnSpc>
@@ -2698,7 +2662,7 @@
           <a:sym typeface="Calibri"/>
         </a:defRPr>
       </a:lvl8pPr>
-      <a:lvl9pPr marL="0" marR="0" indent="3657600" algn="r" defTabSz="457200" rtl="0" latinLnBrk="0">
+      <a:lvl9pPr marL="0" marR="0" indent="0" algn="r" defTabSz="457200" rtl="0" latinLnBrk="0">
         <a:lnSpc>
           <a:spcPct val="100000"/>
         </a:lnSpc>
@@ -2775,7 +2739,7 @@
           </a:effectLst>
         </p:spPr>
         <p:txBody>
-          <a:bodyPr lIns="45719" rIns="45719" anchor="ctr"/>
+          <a:bodyPr lIns="45718" tIns="45718" rIns="45718" bIns="45718" anchor="ctr"/>
           <a:lstStyle/>
           <a:p>
             <a:pPr algn="ctr">
@@ -2796,8 +2760,8 @@
         </p:nvSpPr>
         <p:spPr>
           <a:xfrm>
-            <a:off x="777239" y="457199"/>
-            <a:ext cx="2547899" cy="340183"/>
+            <a:off x="777238" y="457199"/>
+            <a:ext cx="2547897" cy="340181"/>
           </a:xfrm>
           <a:prstGeom prst="rect">
             <a:avLst/>
@@ -2812,7 +2776,7 @@
           </a:extLst>
         </p:spPr>
         <p:txBody>
-          <a:bodyPr wrap="none" lIns="45719" rIns="45719">
+          <a:bodyPr wrap="none" lIns="45718" tIns="45718" rIns="45718" bIns="45718">
             <a:spAutoFit/>
           </a:bodyPr>
           <a:lstStyle>
@@ -2841,7 +2805,7 @@
         <p:spPr>
           <a:xfrm>
             <a:off x="777239" y="914400"/>
-            <a:ext cx="8548228" cy="581829"/>
+            <a:ext cx="8548225" cy="581828"/>
           </a:xfrm>
           <a:prstGeom prst="rect">
             <a:avLst/>
@@ -2856,7 +2820,7 @@
           </a:extLst>
         </p:spPr>
         <p:txBody>
-          <a:bodyPr wrap="none" lIns="45719" rIns="45719">
+          <a:bodyPr wrap="none" lIns="45718" tIns="45718" rIns="45718" bIns="45718">
             <a:spAutoFit/>
           </a:bodyPr>
           <a:lstStyle>
@@ -2884,8 +2848,8 @@
         </p:nvSpPr>
         <p:spPr>
           <a:xfrm>
-            <a:off x="777239" y="3108960"/>
-            <a:ext cx="5099992" cy="1694791"/>
+            <a:off x="777238" y="3108961"/>
+            <a:ext cx="5099989" cy="1770989"/>
           </a:xfrm>
           <a:prstGeom prst="rect">
             <a:avLst/>
@@ -2900,7 +2864,7 @@
           </a:extLst>
         </p:spPr>
         <p:txBody>
-          <a:bodyPr wrap="none" lIns="45719" rIns="45719">
+          <a:bodyPr wrap="none" lIns="45718" tIns="45718" rIns="45718" bIns="45718">
             <a:spAutoFit/>
           </a:bodyPr>
           <a:lstStyle/>
@@ -2986,8 +2950,8 @@
         </p:nvSpPr>
         <p:spPr>
           <a:xfrm>
-            <a:off x="6903719" y="3108960"/>
-            <a:ext cx="3399041" cy="1351891"/>
+            <a:off x="6903718" y="3108961"/>
+            <a:ext cx="3399039" cy="1428089"/>
           </a:xfrm>
           <a:prstGeom prst="rect">
             <a:avLst/>
@@ -3002,7 +2966,7 @@
           </a:extLst>
         </p:spPr>
         <p:txBody>
-          <a:bodyPr wrap="none" lIns="45719" rIns="45719">
+          <a:bodyPr wrap="none" lIns="45718" tIns="45718" rIns="45718" bIns="45718">
             <a:spAutoFit/>
           </a:bodyPr>
           <a:lstStyle/>
@@ -3120,7 +3084,7 @@
           </a:effectLst>
         </p:spPr>
         <p:txBody>
-          <a:bodyPr lIns="45719" rIns="45719" anchor="ctr"/>
+          <a:bodyPr lIns="45718" tIns="45718" rIns="45718" bIns="45718" anchor="ctr"/>
           <a:lstStyle/>
           <a:p>
             <a:pPr algn="ctr">
@@ -3142,7 +3106,7 @@
         <p:spPr>
           <a:xfrm>
             <a:off x="594360" y="137159"/>
-            <a:ext cx="10881361" cy="497048"/>
+            <a:ext cx="10881361" cy="497046"/>
           </a:xfrm>
           <a:prstGeom prst="rect">
             <a:avLst/>
@@ -3157,7 +3121,7 @@
           </a:extLst>
         </p:spPr>
         <p:txBody>
-          <a:bodyPr lIns="45719" rIns="45719">
+          <a:bodyPr lIns="45718" tIns="45718" rIns="45718" bIns="45718">
             <a:spAutoFit/>
           </a:bodyPr>
           <a:lstStyle>
@@ -3185,8 +3149,8 @@
         </p:nvSpPr>
         <p:spPr>
           <a:xfrm>
-            <a:off x="594360" y="1371600"/>
-            <a:ext cx="10881361" cy="3400882"/>
+            <a:off x="594360" y="1371601"/>
+            <a:ext cx="10881361" cy="3477080"/>
           </a:xfrm>
           <a:prstGeom prst="rect">
             <a:avLst/>
@@ -3201,7 +3165,7 @@
           </a:extLst>
         </p:spPr>
         <p:txBody>
-          <a:bodyPr lIns="45719" rIns="45719">
+          <a:bodyPr lIns="45718" tIns="45718" rIns="45718" bIns="45718">
             <a:spAutoFit/>
           </a:bodyPr>
           <a:lstStyle/>
@@ -3258,12 +3222,12 @@
               <a:spcBef>
                 <a:spcPts val="600"/>
               </a:spcBef>
-            </a:pPr>
-            <a:endParaRPr sz="2000">
-              <a:solidFill>
-                <a:srgbClr val="333333"/>
-              </a:solidFill>
-            </a:endParaRPr>
+              <a:defRPr sz="2000">
+                <a:solidFill>
+                  <a:srgbClr val="333333"/>
+                </a:solidFill>
+              </a:defRPr>
+            </a:pPr>
           </a:p>
           <a:p>
             <a:pPr>
@@ -3382,7 +3346,7 @@
           </a:effectLst>
         </p:spPr>
         <p:txBody>
-          <a:bodyPr lIns="45719" rIns="45719" anchor="ctr"/>
+          <a:bodyPr lIns="45718" tIns="45718" rIns="45718" bIns="45718" anchor="ctr"/>
           <a:lstStyle/>
           <a:p>
             <a:pPr algn="ctr">
@@ -3404,7 +3368,7 @@
         <p:spPr>
           <a:xfrm>
             <a:off x="594360" y="137159"/>
-            <a:ext cx="10881361" cy="497048"/>
+            <a:ext cx="10881361" cy="497046"/>
           </a:xfrm>
           <a:prstGeom prst="rect">
             <a:avLst/>
@@ -3419,7 +3383,7 @@
           </a:extLst>
         </p:spPr>
         <p:txBody>
-          <a:bodyPr lIns="45719" rIns="45719">
+          <a:bodyPr lIns="45718" tIns="45718" rIns="45718" bIns="45718">
             <a:spAutoFit/>
           </a:bodyPr>
           <a:lstStyle>
@@ -3447,8 +3411,8 @@
         </p:nvSpPr>
         <p:spPr>
           <a:xfrm>
-            <a:off x="594360" y="1188719"/>
-            <a:ext cx="5394961" cy="310492"/>
+            <a:off x="594359" y="1188720"/>
+            <a:ext cx="5394962" cy="310489"/>
           </a:xfrm>
           <a:prstGeom prst="rect">
             <a:avLst/>
@@ -3463,7 +3427,7 @@
           </a:extLst>
         </p:spPr>
         <p:txBody>
-          <a:bodyPr lIns="45719" rIns="45719">
+          <a:bodyPr lIns="45718" tIns="45718" rIns="45718" bIns="45718">
             <a:spAutoFit/>
           </a:bodyPr>
           <a:lstStyle>
@@ -3492,7 +3456,7 @@
         <p:spPr>
           <a:xfrm>
             <a:off x="548640" y="1737360"/>
-            <a:ext cx="5486401" cy="3200401"/>
+            <a:ext cx="5486402" cy="3200402"/>
           </a:xfrm>
           <a:prstGeom prst="roundRect">
             <a:avLst>
@@ -3516,7 +3480,7 @@
           </a:effectLst>
         </p:spPr>
         <p:txBody>
-          <a:bodyPr lIns="45719" rIns="45719" anchor="ctr"/>
+          <a:bodyPr lIns="45718" tIns="45718" rIns="45718" bIns="45718" anchor="ctr"/>
           <a:lstStyle/>
           <a:p>
             <a:pPr algn="ctr">
@@ -3537,8 +3501,8 @@
         </p:nvSpPr>
         <p:spPr>
           <a:xfrm>
-            <a:off x="777239" y="1828799"/>
-            <a:ext cx="3571806" cy="2110741"/>
+            <a:off x="777238" y="1828800"/>
+            <a:ext cx="3571804" cy="2110739"/>
           </a:xfrm>
           <a:prstGeom prst="rect">
             <a:avLst/>
@@ -3553,7 +3517,7 @@
           </a:extLst>
         </p:spPr>
         <p:txBody>
-          <a:bodyPr wrap="none" lIns="45719" rIns="45719">
+          <a:bodyPr wrap="none" lIns="45718" tIns="45718" rIns="45718" bIns="45718">
             <a:spAutoFit/>
           </a:bodyPr>
           <a:lstStyle/>
@@ -3757,8 +3721,8 @@
         </p:nvSpPr>
         <p:spPr>
           <a:xfrm>
-            <a:off x="6629400" y="1188719"/>
-            <a:ext cx="5212081" cy="310492"/>
+            <a:off x="6629399" y="1188720"/>
+            <a:ext cx="5212083" cy="310489"/>
           </a:xfrm>
           <a:prstGeom prst="rect">
             <a:avLst/>
@@ -3773,7 +3737,7 @@
           </a:extLst>
         </p:spPr>
         <p:txBody>
-          <a:bodyPr lIns="45719" rIns="45719">
+          <a:bodyPr lIns="45718" tIns="45718" rIns="45718" bIns="45718">
             <a:spAutoFit/>
           </a:bodyPr>
           <a:lstStyle>
@@ -3802,7 +3766,7 @@
         <p:spPr>
           <a:xfrm>
             <a:off x="6583680" y="1737360"/>
-            <a:ext cx="5303521" cy="1463040"/>
+            <a:ext cx="5303522" cy="1463040"/>
           </a:xfrm>
           <a:prstGeom prst="roundRect">
             <a:avLst>
@@ -3826,7 +3790,7 @@
           </a:effectLst>
         </p:spPr>
         <p:txBody>
-          <a:bodyPr lIns="45719" rIns="45719" anchor="ctr"/>
+          <a:bodyPr lIns="45718" tIns="45718" rIns="45718" bIns="45718" anchor="ctr"/>
           <a:lstStyle/>
           <a:p>
             <a:pPr algn="ctr">
@@ -3847,8 +3811,8 @@
         </p:nvSpPr>
         <p:spPr>
           <a:xfrm>
-            <a:off x="6812279" y="1828799"/>
-            <a:ext cx="2779197" cy="688341"/>
+            <a:off x="6812278" y="1828800"/>
+            <a:ext cx="2779195" cy="688339"/>
           </a:xfrm>
           <a:prstGeom prst="rect">
             <a:avLst/>
@@ -3863,7 +3827,7 @@
           </a:extLst>
         </p:spPr>
         <p:txBody>
-          <a:bodyPr wrap="none" lIns="45719" rIns="45719">
+          <a:bodyPr wrap="none" lIns="45718" tIns="45718" rIns="45718" bIns="45718">
             <a:spAutoFit/>
           </a:bodyPr>
           <a:lstStyle/>
@@ -3935,7 +3899,7 @@
         <p:spPr>
           <a:xfrm>
             <a:off x="594360" y="5486399"/>
-            <a:ext cx="5450121" cy="385377"/>
+            <a:ext cx="5450119" cy="385375"/>
           </a:xfrm>
           <a:prstGeom prst="rect">
             <a:avLst/>
@@ -3950,7 +3914,7 @@
           </a:extLst>
         </p:spPr>
         <p:txBody>
-          <a:bodyPr wrap="none" lIns="45719" rIns="45719">
+          <a:bodyPr wrap="none" lIns="45718" tIns="45718" rIns="45718" bIns="45718">
             <a:spAutoFit/>
           </a:bodyPr>
           <a:lstStyle>
@@ -4025,7 +3989,7 @@
           </a:effectLst>
         </p:spPr>
         <p:txBody>
-          <a:bodyPr lIns="45719" rIns="45719" anchor="ctr"/>
+          <a:bodyPr lIns="45718" tIns="45718" rIns="45718" bIns="45718" anchor="ctr"/>
           <a:lstStyle/>
           <a:p>
             <a:pPr algn="ctr">
@@ -4047,7 +4011,7 @@
         <p:spPr>
           <a:xfrm>
             <a:off x="594360" y="137159"/>
-            <a:ext cx="10881361" cy="497048"/>
+            <a:ext cx="10881361" cy="497046"/>
           </a:xfrm>
           <a:prstGeom prst="rect">
             <a:avLst/>
@@ -4062,7 +4026,7 @@
           </a:extLst>
         </p:spPr>
         <p:txBody>
-          <a:bodyPr lIns="45719" rIns="45719">
+          <a:bodyPr lIns="45718" tIns="45718" rIns="45718" bIns="45718">
             <a:spAutoFit/>
           </a:bodyPr>
           <a:lstStyle>
@@ -4091,7 +4055,7 @@
         <p:spPr>
           <a:xfrm>
             <a:off x="594360" y="1371600"/>
-            <a:ext cx="10881361" cy="4092288"/>
+            <a:ext cx="10881361" cy="4168487"/>
           </a:xfrm>
           <a:prstGeom prst="rect">
             <a:avLst/>
@@ -4106,7 +4070,7 @@
           </a:extLst>
         </p:spPr>
         <p:txBody>
-          <a:bodyPr lIns="45719" rIns="45719">
+          <a:bodyPr lIns="45718" tIns="45718" rIns="45718" bIns="45718">
             <a:spAutoFit/>
           </a:bodyPr>
           <a:lstStyle/>
@@ -4133,12 +4097,12 @@
               <a:spcBef>
                 <a:spcPts val="600"/>
               </a:spcBef>
-            </a:pPr>
-            <a:endParaRPr b="1" sz="2200">
-              <a:solidFill>
-                <a:srgbClr val="1B3A5C"/>
-              </a:solidFill>
-            </a:endParaRPr>
+              <a:defRPr b="1" sz="2200">
+                <a:solidFill>
+                  <a:srgbClr val="1B3A5C"/>
+                </a:solidFill>
+              </a:defRPr>
+            </a:pPr>
           </a:p>
           <a:p>
             <a:pPr>
@@ -4156,7 +4120,7 @@
             </a:r>
           </a:p>
           <a:p>
-            <a:pPr lvl="1">
+            <a:pPr lvl="1" indent="457200">
               <a:spcBef>
                 <a:spcPts val="600"/>
               </a:spcBef>
@@ -4171,7 +4135,7 @@
             </a:r>
           </a:p>
           <a:p>
-            <a:pPr lvl="1">
+            <a:pPr lvl="1" indent="457200">
               <a:spcBef>
                 <a:spcPts val="600"/>
               </a:spcBef>
@@ -4186,7 +4150,7 @@
             </a:r>
           </a:p>
           <a:p>
-            <a:pPr lvl="1">
+            <a:pPr lvl="1" indent="457200">
               <a:spcBef>
                 <a:spcPts val="600"/>
               </a:spcBef>
@@ -4205,12 +4169,12 @@
               <a:spcBef>
                 <a:spcPts val="600"/>
               </a:spcBef>
-            </a:pPr>
-            <a:endParaRPr>
-              <a:solidFill>
-                <a:srgbClr val="333333"/>
-              </a:solidFill>
-            </a:endParaRPr>
+              <a:defRPr>
+                <a:solidFill>
+                  <a:srgbClr val="333333"/>
+                </a:solidFill>
+              </a:defRPr>
+            </a:pPr>
           </a:p>
           <a:p>
             <a:pPr>
@@ -4228,7 +4192,7 @@
             </a:r>
           </a:p>
           <a:p>
-            <a:pPr lvl="1">
+            <a:pPr lvl="1" indent="457200">
               <a:spcBef>
                 <a:spcPts val="600"/>
               </a:spcBef>
@@ -4243,7 +4207,7 @@
             </a:r>
           </a:p>
           <a:p>
-            <a:pPr lvl="1">
+            <a:pPr lvl="1" indent="457200">
               <a:spcBef>
                 <a:spcPts val="600"/>
               </a:spcBef>
@@ -4314,7 +4278,7 @@
           </a:effectLst>
         </p:spPr>
         <p:txBody>
-          <a:bodyPr lIns="45719" rIns="45719" anchor="ctr"/>
+          <a:bodyPr lIns="45718" tIns="45718" rIns="45718" bIns="45718" anchor="ctr"/>
           <a:lstStyle/>
           <a:p>
             <a:pPr algn="ctr">
@@ -4336,7 +4300,7 @@
         <p:spPr>
           <a:xfrm>
             <a:off x="594360" y="137159"/>
-            <a:ext cx="10881361" cy="497048"/>
+            <a:ext cx="10881361" cy="497046"/>
           </a:xfrm>
           <a:prstGeom prst="rect">
             <a:avLst/>
@@ -4351,7 +4315,7 @@
           </a:extLst>
         </p:spPr>
         <p:txBody>
-          <a:bodyPr lIns="45719" rIns="45719">
+          <a:bodyPr lIns="45718" tIns="45718" rIns="45718" bIns="45718">
             <a:spAutoFit/>
           </a:bodyPr>
           <a:lstStyle>
@@ -4404,7 +4368,7 @@
           </a:effectLst>
         </p:spPr>
         <p:txBody>
-          <a:bodyPr lIns="45719" rIns="45719" anchor="ctr"/>
+          <a:bodyPr lIns="45718" tIns="45718" rIns="45718" bIns="45718" anchor="ctr"/>
           <a:lstStyle/>
           <a:p>
             <a:pPr algn="ctr">
@@ -4425,8 +4389,8 @@
         </p:nvSpPr>
         <p:spPr>
           <a:xfrm>
-            <a:off x="777239" y="1463039"/>
-            <a:ext cx="7633927" cy="1297941"/>
+            <a:off x="777238" y="1463039"/>
+            <a:ext cx="7633925" cy="1297939"/>
           </a:xfrm>
           <a:prstGeom prst="rect">
             <a:avLst/>
@@ -4441,7 +4405,7 @@
           </a:extLst>
         </p:spPr>
         <p:txBody>
-          <a:bodyPr wrap="none" lIns="45719" rIns="45719">
+          <a:bodyPr wrap="none" lIns="45718" tIns="45718" rIns="45718" bIns="45718">
             <a:spAutoFit/>
           </a:bodyPr>
           <a:lstStyle/>
@@ -4569,8 +4533,8 @@
         </p:nvSpPr>
         <p:spPr>
           <a:xfrm>
-            <a:off x="594360" y="3931920"/>
-            <a:ext cx="10881361" cy="2860388"/>
+            <a:off x="594360" y="3931921"/>
+            <a:ext cx="10881361" cy="2936586"/>
           </a:xfrm>
           <a:prstGeom prst="rect">
             <a:avLst/>
@@ -4585,7 +4549,7 @@
           </a:extLst>
         </p:spPr>
         <p:txBody>
-          <a:bodyPr lIns="45719" rIns="45719">
+          <a:bodyPr lIns="45718" tIns="45718" rIns="45718" bIns="45718">
             <a:spAutoFit/>
           </a:bodyPr>
           <a:lstStyle/>
@@ -4627,12 +4591,12 @@
               <a:spcBef>
                 <a:spcPts val="600"/>
               </a:spcBef>
-            </a:pPr>
-            <a:endParaRPr>
-              <a:solidFill>
-                <a:srgbClr val="333333"/>
-              </a:solidFill>
-            </a:endParaRPr>
+              <a:defRPr>
+                <a:solidFill>
+                  <a:srgbClr val="333333"/>
+                </a:solidFill>
+              </a:defRPr>
+            </a:pPr>
           </a:p>
           <a:p>
             <a:pPr>
@@ -4751,7 +4715,7 @@
           </a:effectLst>
         </p:spPr>
         <p:txBody>
-          <a:bodyPr lIns="45719" rIns="45719" anchor="ctr"/>
+          <a:bodyPr lIns="45718" tIns="45718" rIns="45718" bIns="45718" anchor="ctr"/>
           <a:lstStyle/>
           <a:p>
             <a:pPr algn="ctr">
@@ -4773,7 +4737,7 @@
         <p:spPr>
           <a:xfrm>
             <a:off x="594360" y="137159"/>
-            <a:ext cx="10881361" cy="497048"/>
+            <a:ext cx="10881361" cy="497046"/>
           </a:xfrm>
           <a:prstGeom prst="rect">
             <a:avLst/>
@@ -4788,7 +4752,7 @@
           </a:extLst>
         </p:spPr>
         <p:txBody>
-          <a:bodyPr lIns="45719" rIns="45719">
+          <a:bodyPr lIns="45718" tIns="45718" rIns="45718" bIns="45718">
             <a:spAutoFit/>
           </a:bodyPr>
           <a:lstStyle>
@@ -4841,7 +4805,7 @@
           </a:effectLst>
         </p:spPr>
         <p:txBody>
-          <a:bodyPr lIns="45719" rIns="45719" anchor="ctr"/>
+          <a:bodyPr lIns="45718" tIns="45718" rIns="45718" bIns="45718" anchor="ctr"/>
           <a:lstStyle/>
           <a:p>
             <a:pPr algn="ctr">
@@ -4862,8 +4826,8 @@
         </p:nvSpPr>
         <p:spPr>
           <a:xfrm>
-            <a:off x="777239" y="1463039"/>
-            <a:ext cx="6147785" cy="1501141"/>
+            <a:off x="777238" y="1463039"/>
+            <a:ext cx="6147783" cy="1501139"/>
           </a:xfrm>
           <a:prstGeom prst="rect">
             <a:avLst/>
@@ -4878,7 +4842,7 @@
           </a:extLst>
         </p:spPr>
         <p:txBody>
-          <a:bodyPr wrap="none" lIns="45719" rIns="45719">
+          <a:bodyPr wrap="none" lIns="45718" tIns="45718" rIns="45718" bIns="45718">
             <a:spAutoFit/>
           </a:bodyPr>
           <a:lstStyle/>
@@ -5022,8 +4986,8 @@
         </p:nvSpPr>
         <p:spPr>
           <a:xfrm>
-            <a:off x="594360" y="4389120"/>
-            <a:ext cx="10881361" cy="2111088"/>
+            <a:off x="594360" y="4389121"/>
+            <a:ext cx="10881361" cy="2187286"/>
           </a:xfrm>
           <a:prstGeom prst="rect">
             <a:avLst/>
@@ -5038,7 +5002,7 @@
           </a:extLst>
         </p:spPr>
         <p:txBody>
-          <a:bodyPr lIns="45719" rIns="45719">
+          <a:bodyPr lIns="45718" tIns="45718" rIns="45718" bIns="45718">
             <a:spAutoFit/>
           </a:bodyPr>
           <a:lstStyle/>
@@ -5061,7 +5025,7 @@
             </a:r>
           </a:p>
           <a:p>
-            <a:pPr lvl="1">
+            <a:pPr lvl="1" indent="457200">
               <a:spcBef>
                 <a:spcPts val="600"/>
               </a:spcBef>
@@ -5076,7 +5040,7 @@
             </a:r>
           </a:p>
           <a:p>
-            <a:pPr lvl="1">
+            <a:pPr lvl="1" indent="457200">
               <a:spcBef>
                 <a:spcPts val="600"/>
               </a:spcBef>
@@ -5095,12 +5059,12 @@
               <a:spcBef>
                 <a:spcPts val="600"/>
               </a:spcBef>
-            </a:pPr>
-            <a:endParaRPr>
-              <a:solidFill>
-                <a:srgbClr val="333333"/>
-              </a:solidFill>
-            </a:endParaRPr>
+              <a:defRPr>
+                <a:solidFill>
+                  <a:srgbClr val="333333"/>
+                </a:solidFill>
+              </a:defRPr>
+            </a:pPr>
           </a:p>
           <a:p>
             <a:pPr>
@@ -5174,7 +5138,7 @@
           </a:effectLst>
         </p:spPr>
         <p:txBody>
-          <a:bodyPr lIns="45719" rIns="45719" anchor="ctr"/>
+          <a:bodyPr lIns="45718" tIns="45718" rIns="45718" bIns="45718" anchor="ctr"/>
           <a:lstStyle/>
           <a:p>
             <a:pPr algn="ctr">
@@ -5196,7 +5160,7 @@
         <p:spPr>
           <a:xfrm>
             <a:off x="594360" y="137159"/>
-            <a:ext cx="10881361" cy="497048"/>
+            <a:ext cx="10881361" cy="497046"/>
           </a:xfrm>
           <a:prstGeom prst="rect">
             <a:avLst/>
@@ -5211,7 +5175,7 @@
           </a:extLst>
         </p:spPr>
         <p:txBody>
-          <a:bodyPr lIns="45719" rIns="45719">
+          <a:bodyPr lIns="45718" tIns="45718" rIns="45718" bIns="45718">
             <a:spAutoFit/>
           </a:bodyPr>
           <a:lstStyle>
@@ -5264,7 +5228,7 @@
           </a:effectLst>
         </p:spPr>
         <p:txBody>
-          <a:bodyPr lIns="45719" rIns="45719" anchor="ctr"/>
+          <a:bodyPr lIns="45718" tIns="45718" rIns="45718" bIns="45718" anchor="ctr"/>
           <a:lstStyle/>
           <a:p>
             <a:pPr algn="ctr">
@@ -5285,8 +5249,8 @@
         </p:nvSpPr>
         <p:spPr>
           <a:xfrm>
-            <a:off x="777239" y="1463039"/>
-            <a:ext cx="4166262" cy="1907541"/>
+            <a:off x="777239" y="1463040"/>
+            <a:ext cx="4166260" cy="1907539"/>
           </a:xfrm>
           <a:prstGeom prst="rect">
             <a:avLst/>
@@ -5301,7 +5265,7 @@
           </a:extLst>
         </p:spPr>
         <p:txBody>
-          <a:bodyPr wrap="none" lIns="45719" rIns="45719">
+          <a:bodyPr wrap="none" lIns="45718" tIns="45718" rIns="45718" bIns="45718">
             <a:spAutoFit/>
           </a:bodyPr>
           <a:lstStyle/>
@@ -5486,8 +5450,8 @@
         </p:nvSpPr>
         <p:spPr>
           <a:xfrm>
-            <a:off x="594360" y="5303520"/>
-            <a:ext cx="10881361" cy="993488"/>
+            <a:off x="594360" y="5303521"/>
+            <a:ext cx="10881361" cy="1069686"/>
           </a:xfrm>
           <a:prstGeom prst="rect">
             <a:avLst/>
@@ -5502,7 +5466,7 @@
           </a:extLst>
         </p:spPr>
         <p:txBody>
-          <a:bodyPr lIns="45719" rIns="45719">
+          <a:bodyPr lIns="45718" tIns="45718" rIns="45718" bIns="45718">
             <a:spAutoFit/>
           </a:bodyPr>
           <a:lstStyle/>
@@ -5596,7 +5560,7 @@
           </a:effectLst>
         </p:spPr>
         <p:txBody>
-          <a:bodyPr lIns="45719" rIns="45719" anchor="ctr"/>
+          <a:bodyPr lIns="45718" tIns="45718" rIns="45718" bIns="45718" anchor="ctr"/>
           <a:lstStyle/>
           <a:p>
             <a:pPr algn="ctr">
@@ -5618,7 +5582,7 @@
         <p:spPr>
           <a:xfrm>
             <a:off x="594360" y="137159"/>
-            <a:ext cx="10881361" cy="497048"/>
+            <a:ext cx="10881361" cy="497046"/>
           </a:xfrm>
           <a:prstGeom prst="rect">
             <a:avLst/>
@@ -5633,7 +5597,7 @@
           </a:extLst>
         </p:spPr>
         <p:txBody>
-          <a:bodyPr lIns="45719" rIns="45719">
+          <a:bodyPr lIns="45718" tIns="45718" rIns="45718" bIns="45718">
             <a:spAutoFit/>
           </a:bodyPr>
           <a:lstStyle>
@@ -5686,7 +5650,7 @@
           </a:effectLst>
         </p:spPr>
         <p:txBody>
-          <a:bodyPr lIns="45719" rIns="45719" anchor="ctr"/>
+          <a:bodyPr lIns="45718" tIns="45718" rIns="45718" bIns="45718" anchor="ctr"/>
           <a:lstStyle/>
           <a:p>
             <a:pPr algn="ctr">
@@ -5707,8 +5671,8 @@
         </p:nvSpPr>
         <p:spPr>
           <a:xfrm>
-            <a:off x="777239" y="1463039"/>
-            <a:ext cx="3571806" cy="1704341"/>
+            <a:off x="777238" y="1463040"/>
+            <a:ext cx="3571804" cy="1704339"/>
           </a:xfrm>
           <a:prstGeom prst="rect">
             <a:avLst/>
@@ -5723,7 +5687,7 @@
           </a:extLst>
         </p:spPr>
         <p:txBody>
-          <a:bodyPr wrap="none" lIns="45719" rIns="45719">
+          <a:bodyPr wrap="none" lIns="45718" tIns="45718" rIns="45718" bIns="45718">
             <a:spAutoFit/>
           </a:bodyPr>
           <a:lstStyle/>
@@ -5883,8 +5847,8 @@
         </p:nvSpPr>
         <p:spPr>
           <a:xfrm>
-            <a:off x="8458200" y="1371600"/>
-            <a:ext cx="3474720" cy="1821791"/>
+            <a:off x="8458199" y="1371601"/>
+            <a:ext cx="3474722" cy="1897989"/>
           </a:xfrm>
           <a:prstGeom prst="rect">
             <a:avLst/>
@@ -5899,7 +5863,7 @@
           </a:extLst>
         </p:spPr>
         <p:txBody>
-          <a:bodyPr lIns="45719" rIns="45719">
+          <a:bodyPr lIns="45718" tIns="45718" rIns="45718" bIns="45718">
             <a:spAutoFit/>
           </a:bodyPr>
           <a:lstStyle/>
@@ -5926,12 +5890,12 @@
               <a:spcBef>
                 <a:spcPts val="600"/>
               </a:spcBef>
-            </a:pPr>
-            <a:endParaRPr b="1" sz="1700">
-              <a:solidFill>
-                <a:srgbClr val="1B3A5C"/>
-              </a:solidFill>
-            </a:endParaRPr>
+              <a:defRPr b="1" sz="1700">
+                <a:solidFill>
+                  <a:srgbClr val="1B3A5C"/>
+                </a:solidFill>
+              </a:defRPr>
+            </a:pPr>
           </a:p>
           <a:p>
             <a:pPr>
@@ -6005,7 +5969,7 @@
           </a:effectLst>
         </p:spPr>
         <p:txBody>
-          <a:bodyPr lIns="45719" rIns="45719" anchor="ctr"/>
+          <a:bodyPr lIns="45718" tIns="45718" rIns="45718" bIns="45718" anchor="ctr"/>
           <a:lstStyle/>
           <a:p>
             <a:pPr algn="ctr">
@@ -6027,7 +5991,7 @@
         <p:spPr>
           <a:xfrm>
             <a:off x="594360" y="137159"/>
-            <a:ext cx="10881361" cy="497048"/>
+            <a:ext cx="10881361" cy="497046"/>
           </a:xfrm>
           <a:prstGeom prst="rect">
             <a:avLst/>
@@ -6042,7 +6006,7 @@
           </a:extLst>
         </p:spPr>
         <p:txBody>
-          <a:bodyPr lIns="45719" rIns="45719">
+          <a:bodyPr lIns="45718" tIns="45718" rIns="45718" bIns="45718">
             <a:spAutoFit/>
           </a:bodyPr>
           <a:lstStyle>
@@ -6095,7 +6059,7 @@
           </a:effectLst>
         </p:spPr>
         <p:txBody>
-          <a:bodyPr lIns="45719" rIns="45719" anchor="ctr"/>
+          <a:bodyPr lIns="45718" tIns="45718" rIns="45718" bIns="45718" anchor="ctr"/>
           <a:lstStyle/>
           <a:p>
             <a:pPr algn="ctr">
@@ -6116,8 +6080,8 @@
         </p:nvSpPr>
         <p:spPr>
           <a:xfrm>
-            <a:off x="2057399" y="1463039"/>
-            <a:ext cx="5743859" cy="2517141"/>
+            <a:off x="2057398" y="1463039"/>
+            <a:ext cx="5743857" cy="2517139"/>
           </a:xfrm>
           <a:prstGeom prst="rect">
             <a:avLst/>
@@ -6132,7 +6096,7 @@
           </a:extLst>
         </p:spPr>
         <p:txBody>
-          <a:bodyPr wrap="none" lIns="45719" rIns="45719">
+          <a:bodyPr wrap="none" lIns="45718" tIns="45718" rIns="45718" bIns="45718">
             <a:spAutoFit/>
           </a:bodyPr>
           <a:lstStyle/>
@@ -6298,8 +6262,8 @@
         </p:nvSpPr>
         <p:spPr>
           <a:xfrm>
-            <a:off x="594360" y="5303520"/>
-            <a:ext cx="10881361" cy="1064082"/>
+            <a:off x="594360" y="5303521"/>
+            <a:ext cx="10881361" cy="1140280"/>
           </a:xfrm>
           <a:prstGeom prst="rect">
             <a:avLst/>
@@ -6314,7 +6278,7 @@
           </a:extLst>
         </p:spPr>
         <p:txBody>
-          <a:bodyPr lIns="45719" rIns="45719">
+          <a:bodyPr lIns="45718" tIns="45718" rIns="45718" bIns="45718">
             <a:spAutoFit/>
           </a:bodyPr>
           <a:lstStyle/>
@@ -6408,7 +6372,7 @@
           </a:effectLst>
         </p:spPr>
         <p:txBody>
-          <a:bodyPr lIns="45719" rIns="45719" anchor="ctr"/>
+          <a:bodyPr lIns="45718" tIns="45718" rIns="45718" bIns="45718" anchor="ctr"/>
           <a:lstStyle/>
           <a:p>
             <a:pPr algn="ctr">
@@ -6430,7 +6394,7 @@
         <p:spPr>
           <a:xfrm>
             <a:off x="594360" y="137159"/>
-            <a:ext cx="10881361" cy="497048"/>
+            <a:ext cx="10881361" cy="497046"/>
           </a:xfrm>
           <a:prstGeom prst="rect">
             <a:avLst/>
@@ -6445,7 +6409,7 @@
           </a:extLst>
         </p:spPr>
         <p:txBody>
-          <a:bodyPr lIns="45719" rIns="45719">
+          <a:bodyPr lIns="45718" tIns="45718" rIns="45718" bIns="45718">
             <a:spAutoFit/>
           </a:bodyPr>
           <a:lstStyle>
@@ -6473,8 +6437,8 @@
         </p:nvSpPr>
         <p:spPr>
           <a:xfrm>
-            <a:off x="594360" y="1371600"/>
-            <a:ext cx="5852161" cy="2885788"/>
+            <a:off x="594359" y="1371600"/>
+            <a:ext cx="5852162" cy="2961987"/>
           </a:xfrm>
           <a:prstGeom prst="rect">
             <a:avLst/>
@@ -6489,7 +6453,7 @@
           </a:extLst>
         </p:spPr>
         <p:txBody>
-          <a:bodyPr lIns="45719" rIns="45719">
+          <a:bodyPr lIns="45718" tIns="45718" rIns="45718" bIns="45718">
             <a:spAutoFit/>
           </a:bodyPr>
           <a:lstStyle/>
@@ -6527,7 +6491,7 @@
             </a:r>
           </a:p>
           <a:p>
-            <a:pPr lvl="1">
+            <a:pPr lvl="1" indent="457200">
               <a:spcBef>
                 <a:spcPts val="600"/>
               </a:spcBef>
@@ -6542,7 +6506,7 @@
             </a:r>
           </a:p>
           <a:p>
-            <a:pPr lvl="1">
+            <a:pPr lvl="1" indent="457200">
               <a:spcBef>
                 <a:spcPts val="600"/>
               </a:spcBef>
@@ -6561,12 +6525,12 @@
               <a:spcBef>
                 <a:spcPts val="600"/>
               </a:spcBef>
-            </a:pPr>
-            <a:endParaRPr sz="1700">
-              <a:solidFill>
-                <a:srgbClr val="333333"/>
-              </a:solidFill>
-            </a:endParaRPr>
+              <a:defRPr sz="1700">
+                <a:solidFill>
+                  <a:srgbClr val="333333"/>
+                </a:solidFill>
+              </a:defRPr>
+            </a:pPr>
           </a:p>
           <a:p>
             <a:pPr>
@@ -6609,7 +6573,7 @@
         <p:spPr>
           <a:xfrm>
             <a:off x="6583680" y="2286000"/>
-            <a:ext cx="5303521" cy="1645921"/>
+            <a:ext cx="5303522" cy="1645922"/>
           </a:xfrm>
           <a:prstGeom prst="roundRect">
             <a:avLst>
@@ -6633,7 +6597,7 @@
           </a:effectLst>
         </p:spPr>
         <p:txBody>
-          <a:bodyPr lIns="45719" rIns="45719" anchor="ctr"/>
+          <a:bodyPr lIns="45718" tIns="45718" rIns="45718" bIns="45718" anchor="ctr"/>
           <a:lstStyle/>
           <a:p>
             <a:pPr algn="ctr">
@@ -6654,8 +6618,8 @@
         </p:nvSpPr>
         <p:spPr>
           <a:xfrm>
-            <a:off x="6812279" y="2377439"/>
-            <a:ext cx="4356793" cy="878841"/>
+            <a:off x="6812278" y="2377439"/>
+            <a:ext cx="4356791" cy="878839"/>
           </a:xfrm>
           <a:prstGeom prst="rect">
             <a:avLst/>
@@ -6670,7 +6634,7 @@
           </a:extLst>
         </p:spPr>
         <p:txBody>
-          <a:bodyPr wrap="none" lIns="45719" rIns="45719">
+          <a:bodyPr wrap="none" lIns="45718" tIns="45718" rIns="45718" bIns="45718">
             <a:spAutoFit/>
           </a:bodyPr>
           <a:lstStyle/>
@@ -6887,9 +6851,9 @@
         </a:effectStyle>
         <a:effectStyle>
           <a:effectLst>
-            <a:outerShdw sx="100000" sy="100000" kx="0" ky="0" algn="b" rotWithShape="0" blurRad="38100" dist="20000" dir="5400000">
+            <a:outerShdw sx="100000" sy="100000" kx="0" ky="0" algn="b" rotWithShape="0" blurRad="38100" dist="23000" dir="5400000">
               <a:srgbClr val="000000">
-                <a:alpha val="38000"/>
+                <a:alpha val="35000"/>
               </a:srgbClr>
             </a:outerShdw>
           </a:effectLst>
@@ -6969,7 +6933,7 @@
         </a:effectLst>
         <a:sp3d/>
       </a:spPr>
-      <a:bodyPr rot="0" spcFirstLastPara="1" vertOverflow="overflow" horzOverflow="overflow" vert="horz" wrap="square" lIns="45719" tIns="45719" rIns="45719" bIns="45719" numCol="1" spcCol="38100" rtlCol="0" anchor="ctr" upright="0">
+      <a:bodyPr rot="0" spcFirstLastPara="1" vertOverflow="overflow" horzOverflow="overflow" vert="horz" wrap="square" lIns="45718" tIns="45718" rIns="45718" bIns="45718" numCol="1" spcCol="38100" rtlCol="0" anchor="ctr" upright="0">
         <a:spAutoFit/>
       </a:bodyPr>
       <a:lstStyle>
@@ -7256,9 +7220,9 @@
           <a:round/>
         </a:ln>
         <a:effectLst>
-          <a:outerShdw sx="100000" sy="100000" kx="0" ky="0" algn="b" rotWithShape="0" blurRad="38100" dist="20000" dir="5400000">
+          <a:outerShdw sx="100000" sy="100000" kx="0" ky="0" algn="b" rotWithShape="0" blurRad="38100" dist="23000" dir="5400000">
             <a:srgbClr val="000000">
-              <a:alpha val="38000"/>
+              <a:alpha val="35000"/>
             </a:srgbClr>
           </a:outerShdw>
         </a:effectLst>
@@ -7546,7 +7510,7 @@
         <a:effectLst/>
         <a:sp3d/>
       </a:spPr>
-      <a:bodyPr rot="0" spcFirstLastPara="1" vertOverflow="overflow" horzOverflow="overflow" vert="horz" wrap="square" lIns="45719" tIns="45719" rIns="45719" bIns="45719" numCol="1" spcCol="38100" rtlCol="0" anchor="t" upright="0">
+      <a:bodyPr rot="0" spcFirstLastPara="1" vertOverflow="overflow" horzOverflow="overflow" vert="horz" wrap="square" lIns="45718" tIns="45718" rIns="45718" bIns="45718" numCol="1" spcCol="38100" rtlCol="0" anchor="t" upright="0">
         <a:spAutoFit/>
       </a:bodyPr>
       <a:lstStyle>
@@ -7971,9 +7935,9 @@
         </a:effectStyle>
         <a:effectStyle>
           <a:effectLst>
-            <a:outerShdw sx="100000" sy="100000" kx="0" ky="0" algn="b" rotWithShape="0" blurRad="38100" dist="20000" dir="5400000">
+            <a:outerShdw sx="100000" sy="100000" kx="0" ky="0" algn="b" rotWithShape="0" blurRad="38100" dist="23000" dir="5400000">
               <a:srgbClr val="000000">
-                <a:alpha val="38000"/>
+                <a:alpha val="35000"/>
               </a:srgbClr>
             </a:outerShdw>
           </a:effectLst>
@@ -8053,7 +8017,7 @@
         </a:effectLst>
         <a:sp3d/>
       </a:spPr>
-      <a:bodyPr rot="0" spcFirstLastPara="1" vertOverflow="overflow" horzOverflow="overflow" vert="horz" wrap="square" lIns="45719" tIns="45719" rIns="45719" bIns="45719" numCol="1" spcCol="38100" rtlCol="0" anchor="ctr" upright="0">
+      <a:bodyPr rot="0" spcFirstLastPara="1" vertOverflow="overflow" horzOverflow="overflow" vert="horz" wrap="square" lIns="45718" tIns="45718" rIns="45718" bIns="45718" numCol="1" spcCol="38100" rtlCol="0" anchor="ctr" upright="0">
         <a:spAutoFit/>
       </a:bodyPr>
       <a:lstStyle>
@@ -8340,9 +8304,9 @@
           <a:round/>
         </a:ln>
         <a:effectLst>
-          <a:outerShdw sx="100000" sy="100000" kx="0" ky="0" algn="b" rotWithShape="0" blurRad="38100" dist="20000" dir="5400000">
+          <a:outerShdw sx="100000" sy="100000" kx="0" ky="0" algn="b" rotWithShape="0" blurRad="38100" dist="23000" dir="5400000">
             <a:srgbClr val="000000">
-              <a:alpha val="38000"/>
+              <a:alpha val="35000"/>
             </a:srgbClr>
           </a:outerShdw>
         </a:effectLst>
@@ -8630,7 +8594,7 @@
         <a:effectLst/>
         <a:sp3d/>
       </a:spPr>
-      <a:bodyPr rot="0" spcFirstLastPara="1" vertOverflow="overflow" horzOverflow="overflow" vert="horz" wrap="square" lIns="45719" tIns="45719" rIns="45719" bIns="45719" numCol="1" spcCol="38100" rtlCol="0" anchor="t" upright="0">
+      <a:bodyPr rot="0" spcFirstLastPara="1" vertOverflow="overflow" horzOverflow="overflow" vert="horz" wrap="square" lIns="45718" tIns="45718" rIns="45718" bIns="45718" numCol="1" spcCol="38100" rtlCol="0" anchor="t" upright="0">
         <a:spAutoFit/>
       </a:bodyPr>
       <a:lstStyle>

</xml_diff>